<commit_message>
W04 D4: the decks hold each rule to its condition, ask predictions the ticket does not answer, and size what the flat 38 is made of
Co-Authored-By: Claude Opus 5.5 <noreply@anthropic.com>
Claude-Session: https://claude.ai/code/session_01TvM13LJMo8DngoahNnqaWr
</commit_message>
<xml_diff>
--- a/content/W04/D4/slides/C2_W04_D04_half2_STUDENT.pptx
+++ b/content/W04/D4/slides/C2_W04_D04_half2_STUDENT.pptx
@@ -539,7 +539,12 @@
           </a:p>
           <a:p>
             <a:r>
-              <a:t>LIVE, 10 minutes. Laptops closed; notebook 08 afterwards or in the lab. Styles: Veritasium (the</a:t>
+              <a:t>LIVE, 10 minutes. Laptops closed; notebook 08 afterwards or in the lab; drill c5 runs in the lab.</a:t>
+            </a:r>
+          </a:p>
+          <a:p>
+            <a:r>
+              <a:t>If late: S70 in one sentence. Styles: Veritasium (the</a:t>
             </a:r>
           </a:p>
           <a:p>
@@ -714,12 +719,17 @@
           <a:lstStyle/>
           <a:p>
             <a:r>
-              <a:t>LIVE, 3 minutes. A learner reads the role card aloud (TRAINER role card); one group answers in</a:t>
-            </a:r>
-          </a:p>
-          <a:p>
-            <a:r>
-              <a:t>the four moves from Tuesday: restate, answer from the evidence, concede what is true, say what</a:t>
+              <a:t>LIVE, 3 minutes. Keep S73 up while the TA, playing the app team's lead from the role card (TRAINER</a:t>
+            </a:r>
+          </a:p>
+          <a:p>
+            <a:r>
+              <a:t>role card), reads the claim; one group answers in the four moves from Tuesday, and only then does</a:t>
+            </a:r>
+          </a:p>
+          <a:p>
+            <a:r>
+              <a:t>this slide, the model answer, go up. The four moves: restate, answer from the evidence, concede what is true, say what</a:t>
             </a:r>
           </a:p>
           <a:p>
@@ -914,12 +924,12 @@
           </a:p>
           <a:p>
             <a:r>
-              <a:t>weaned away more than 4 million unprofitable Instamart users (its Q1 FY27 letter, the fallback</a:t>
-            </a:r>
-          </a:p>
-          <a:p>
-            <a:r>
-              <a:t>block's first part). Then the groups finish their page.</a:t>
+              <a:t>weaned away more than 4 million unprofitable Instamart users (its Q1 FY27 letter; the fallback</a:t>
+            </a:r>
+          </a:p>
+          <a:p>
+            <a:r>
+              <a:t>deck opens on it). Then the groups finish their page.</a:t>
             </a:r>
           </a:p>
           <a:p>
@@ -1089,17 +1099,17 @@
           <a:lstStyle/>
           <a:p>
             <a:r>
-              <a:t>LIVE, 10 minutes. L6. Pairs read the transcript in the extras folder: one plays the interviewer,</a:t>
-            </a:r>
-          </a:p>
-          <a:p>
-            <a:r>
-              <a:t>one the candidate; they score the hire-grade answer on the scorecard's seven lines and swap.</a:t>
-            </a:r>
-          </a:p>
-          <a:p>
-            <a:r>
-              <a:t>Explorer scene Th4 carries the AI-company variant.</a:t>
+              <a:t>LIVE, 10 minutes. L6. Pairs work from S79's table only: one asks the question, one answers in the</a:t>
+            </a:r>
+          </a:p>
+          <a:p>
+            <a:r>
+              <a:t>hire-grade order, and they swap; the full transcript in the extras folder is for the evening. The</a:t>
+            </a:r>
+          </a:p>
+          <a:p>
+            <a:r>
+              <a:t>AI variant is read aloud, 3 minutes, no discussion; explorer scene Th4 carries it.</a:t>
             </a:r>
           </a:p>
           <a:p>
@@ -1249,7 +1259,27 @@
           <a:lstStyle/>
           <a:p>
             <a:r>
-              <a:t>LIVE, 5 minutes. The steps are the morning's hypothesis board. Aced's guide to analyst interviews</a:t>
+              <a:t>LIVE, 5 minutes. Pairs read only this table: one asks, one answers in the hire-grade order, then</a:t>
+            </a:r>
+          </a:p>
+          <a:p>
+            <a:r>
+              <a:t>swap. The 3.6 and the 3.2, worked: counted for everyone, the month read 39.5 in August and 35.9 in</a:t>
+            </a:r>
+          </a:p>
+          <a:p>
+            <a:r>
+              <a:t>September, a fall of 3.6 points; with a normal August cohort, 5,000 members at July's 49 percent in</a:t>
+            </a:r>
+          </a:p>
+          <a:p>
+            <a:r>
+              <a:t>month one, September would read 39.2, a fall of about 0.4, so about 3.2 of the 3.6 is the August</a:t>
+            </a:r>
+          </a:p>
+          <a:p>
+            <a:r>
+              <a:t>cohort. The steps are the morning's hypothesis board. Aced's guide to analyst interviews</a:t>
             </a:r>
           </a:p>
           <a:p>
@@ -1599,7 +1629,12 @@
           <a:lstStyle/>
           <a:p>
             <a:r>
-              <a:t>LIVE, 15 minutes. The map (1), the Kahoot (10) and the close (4).</a:t>
+              <a:t>LIVE, 15 minutes. The two questions (1), the Kahoot (10) and the close (4). If late: the close</a:t>
+            </a:r>
+          </a:p>
+          <a:p>
+            <a:r>
+              <a:t>keeps the sentence and Friday's ticket.</a:t>
             </a:r>
           </a:p>
           <a:p>
@@ -2399,7 +2434,17 @@
           <a:lstStyle/>
           <a:p>
             <a:r>
-              <a:t>LIVE, 25 minutes, unguided, in the nine groups. L5. Styles: the case method (the app team's lead</a:t>
+              <a:t>LIVE, 25 minutes, unguided, in the nine groups: 12 minutes of slides and 13 of writing; the set's</a:t>
+            </a:r>
+          </a:p>
+          <a:p>
+            <a:r>
+              <a:t>items run in the lab. Hand out: the fix-first set and the role card to the TA. If late: S76 in one</a:t>
+            </a:r>
+          </a:p>
+          <a:p>
+            <a:r>
+              <a:t>sentence. L5. Styles: the case method (the app team's lead</a:t>
             </a:r>
           </a:p>
           <a:p>
@@ -10529,7 +10574,7 @@
                 </a:solidFill>
                 <a:latin typeface="Calibri"/>
               </a:rPr>
-              <a:t>Before buying another sale, set what a sale-week member returns against her discount: 0.23 orders in month one against 0.61 for an organic member, so this sale has not paid back. Leave search to menu view alone: 118 percent was never a broken step.</a:t>
+              <a:t>Before another sale, set a sale-week member's 0.23 orders in month one, against an organic member's 0.61, beside her discount and the margin; until then the payback is open. Leave search to menu view alone: 118 was never a broken step.</a:t>
             </a:r>
           </a:p>
         </p:txBody>
@@ -11135,7 +11180,7 @@
         <p:spPr>
           <a:xfrm>
             <a:off x="530352" y="1956816"/>
-            <a:ext cx="11130991" cy="3208020"/>
+            <a:ext cx="11130991" cy="3741420"/>
           </a:xfrm>
           <a:prstGeom prst="roundRect">
             <a:avLst>
@@ -11183,7 +11228,7 @@
         <p:spPr>
           <a:xfrm>
             <a:off x="676656" y="2084832"/>
-            <a:ext cx="45720" cy="2951988"/>
+            <a:ext cx="45720" cy="3485388"/>
           </a:xfrm>
           <a:prstGeom prst="roundRect">
             <a:avLst>
@@ -11229,7 +11274,7 @@
         <p:spPr>
           <a:xfrm>
             <a:off x="877824" y="2075688"/>
-            <a:ext cx="10564063" cy="3025140"/>
+            <a:ext cx="10564063" cy="3558540"/>
           </a:xfrm>
           <a:prstGeom prst="rect">
             <a:avLst/>
@@ -11258,7 +11303,7 @@
                 </a:solidFill>
                 <a:latin typeface="Calibri"/>
               </a:rPr>
-              <a:t>Fix the member path of the new Android checkout first: it loses about 1,133 to 1,317 orders a week, a quarter of Android members' orders, and non-members on the same checkout held, so the fault sits in what only members see. </a:t>
+              <a:t>Fix the member path of the new Android checkout first: it loses about 1,133 to 1,317 orders a week, a quarter of Android members' orders, and non-members on the same checkout held, so the fault sits in what only members see. Until the fix ships, switch Android members back to the old checkout today, or give half of them the old path for two days, which confirms the cause and stops most of the loss. </a:t>
             </a:r>
             <a:r>
               <a:rPr sz="1500" b="1" i="0">
@@ -14282,7 +14327,7 @@
                           </a:solidFill>
                           <a:latin typeface="Calibri"/>
                         </a:rPr>
-                        <a:t>"About 3.2 of the 3.6-point fall is the August cohort; the checkout loses 1,133 to 1,317 orders a week that retention cannot see; then whether the sale paid back; October reads about 33."</a:t>
+                        <a:t>"About 3.2 of the 3.6-point fall is the August cohort; the checkout loses 1,133 to 1,317 orders a week that retention cannot see; then whether the sale pays back; October reads about 33 on one assumption."</a:t>
                       </a:r>
                     </a:p>
                   </a:txBody>
@@ -15940,7 +15985,7 @@
         <p:spPr>
           <a:xfrm>
             <a:off x="530352" y="1956816"/>
-            <a:ext cx="11130991" cy="1074420"/>
+            <a:ext cx="11130991" cy="1341120"/>
           </a:xfrm>
           <a:prstGeom prst="roundRect">
             <a:avLst>
@@ -15988,7 +16033,7 @@
         <p:spPr>
           <a:xfrm>
             <a:off x="676656" y="2084832"/>
-            <a:ext cx="45720" cy="818388"/>
+            <a:ext cx="45720" cy="1085088"/>
           </a:xfrm>
           <a:prstGeom prst="roundRect">
             <a:avLst>
@@ -16034,7 +16079,7 @@
         <p:spPr>
           <a:xfrm>
             <a:off x="877824" y="2075688"/>
-            <a:ext cx="10564063" cy="891540"/>
+            <a:ext cx="10564063" cy="1158240"/>
           </a:xfrm>
           <a:prstGeom prst="rect">
             <a:avLst/>
@@ -16063,7 +16108,7 @@
                 </a:solidFill>
                 <a:latin typeface="Calibri"/>
               </a:rPr>
-              <a:t>"Your cohort table treats a member who has not left yet as if she were retained for ever, and that flatters every curve. The next 120 minutes give that member a name, censored, and show when two curves really differ by more than chance."</a:t>
+              <a:t>"Your table leaves a young cohort's later ages empty, and a member who has not left yet has no end date. Treat her as retained for ever and every curve looks better than it is. After the close, the faculty session (tentative) gives that member a name, censored, and shows when two curves really differ by more than chance."</a:t>
             </a:r>
           </a:p>
         </p:txBody>
@@ -16076,7 +16121,7 @@
         </p:nvSpPr>
         <p:spPr>
           <a:xfrm>
-            <a:off x="530352" y="3195828"/>
+            <a:off x="530352" y="3462528"/>
             <a:ext cx="11130991" cy="772160"/>
           </a:xfrm>
           <a:prstGeom prst="rect">
@@ -19407,7 +19452,7 @@
                 </a:solidFill>
                 <a:latin typeface="Calibri"/>
               </a:rPr>
-              <a:t>One Kahoot item per topic, and Wednesday's return question</a:t>
+              <a:t>At least one Kahoot item per topic, and Wednesday's return question</a:t>
             </a:r>
           </a:p>
         </p:txBody>
@@ -20895,7 +20940,7 @@
                 </a:solidFill>
                 <a:latin typeface="Calibri"/>
               </a:rPr>
-              <a:t>The first move in a retention walk; then bread to milk, confidence 0.74 and lift 1.04, the verdict in one breath</a:t>
+              <a:t>Which of Gold's two problems goes first, and why; then bread to milk, confidence 0.74 and lift 1.04, the verdict in one breath</a:t>
             </a:r>
           </a:p>
         </p:txBody>
@@ -21624,7 +21669,7 @@
                 </a:solidFill>
                 <a:latin typeface="Calibri"/>
               </a:rPr>
-              <a:t>The dashboard was flat because of who it counts: every cohort fell after month one, each newer one started lower, and the August cohort is outside the count until October, when the dashboard reads about 33; the orders were lost in one step, on one platform, after one date.</a:t>
+              <a:t>The dashboard was flat because of who it counts: every cohort fell after month one, each newer one started lower, and the August cohort is outside the count until October, when the dashboard, on one assumption, reads about 33; the orders were lost in one step, on one platform, after one date.</a:t>
             </a:r>
           </a:p>
         </p:txBody>
@@ -21761,7 +21806,7 @@
                 </a:solidFill>
                 <a:latin typeface="Calibri"/>
               </a:rPr>
-              <a:t>A cohort fixes the entry moment. A curve's floor is read only once two ages agree. A blend is a size-weighted average and counts who it counts. Each funnel step divides by the step before, in one named unit. A low step is not a loss until it moves, and a fix-first call carries its comparator, its date and its cost.</a:t>
+              <a:t>A cohort fixes the entry moment. A curve's floor, by our rule, is read only once two ages agree within a point. A blend is a size-weighted average and counts who it counts. Each funnel step divides by the step before, in one named unit. When the overall falls, the step that moved owns the fall, and a fix-first call carries its comparator, its date and its cost.</a:t>
             </a:r>
           </a:p>
         </p:txBody>
@@ -22490,7 +22535,7 @@
                 </a:solidFill>
                 <a:latin typeface="Calibri"/>
               </a:rPr>
-              <a:t>The dean has two problems: 200 of 1,000 applications skip the entrance test every cycle, and offer acceptance fell from 90 to 75 percent this cycle (invented). Which goes first?</a:t>
+              <a:t>The dean has two problems: 200 of 1,000 applications never sat the entrance test this cycle, the same 20 percent as every cycle, and offer acceptance fell from 90 to 75 percent (invented). Which goes first?</a:t>
             </a:r>
           </a:p>
         </p:txBody>
@@ -23488,8 +23533,8 @@
         </p:blipFill>
         <p:spPr>
           <a:xfrm>
-            <a:off x="2687132" y="1664208"/>
-            <a:ext cx="6817429" cy="2939287"/>
+            <a:off x="3007620" y="1664208"/>
+            <a:ext cx="6176454" cy="2662936"/>
           </a:xfrm>
           <a:prstGeom prst="rect">
             <a:avLst/>
@@ -23504,7 +23549,7 @@
         </p:nvSpPr>
         <p:spPr>
           <a:xfrm>
-            <a:off x="530352" y="4640072"/>
+            <a:off x="530352" y="4363720"/>
             <a:ext cx="11130991" cy="316992"/>
           </a:xfrm>
           <a:prstGeom prst="rect">
@@ -23539,8 +23584,8 @@
         </p:nvSpPr>
         <p:spPr>
           <a:xfrm>
-            <a:off x="530352" y="4966208"/>
-            <a:ext cx="11130991" cy="1233424"/>
+            <a:off x="530352" y="4689856"/>
+            <a:ext cx="11130991" cy="1509775"/>
           </a:xfrm>
           <a:prstGeom prst="rect">
             <a:avLst/>
@@ -23560,7 +23605,7 @@
                 </a:solidFill>
                 <a:latin typeface="Calibri"/>
               </a:rPr>
-              <a:t>The answer is c. The test's no-show has read 20 percent for three cycles, so it is how the test runs, and nothing changed there. Acceptance fell for one group: students from other states went from 87 to 50 percent, from the cycle the fee-payment deadline was cut from 21 to 7 days after the offer, while in-state students, the comparator on the same step, held at 92 to 90.</a:t>
+              <a:t>The answer is c. The test's no-show has read 20 percent for three cycles, so it is how the test runs, and nothing changed there. Acceptance fell for one group: students from other states went from 87 to 50 percent, from the cycle the fee-payment deadline was cut from 21 to 7 days after the offer, while in-state students on the same step, who met the same shorter deadline, held at 92 to 90: the comparator places the fall in one group, and the date ties it to the change.</a:t>
             </a:r>
           </a:p>
         </p:txBody>
@@ -24166,8 +24211,8 @@
           <p:nvPr/>
         </p:nvGraphicFramePr>
         <p:xfrm>
-          <a:off x="530352" y="1905508"/>
-          <a:ext cx="11130990" cy="1676400"/>
+          <a:off x="530352" y="1812544"/>
+          <a:ext cx="11130991" cy="1554480"/>
         </p:xfrm>
         <a:graphic>
           <a:graphicData uri="http://schemas.openxmlformats.org/drawingml/2006/table">
@@ -24176,19 +24221,19 @@
                 <a:tableStyleId>{2D5ABB26-0587-4C30-8999-92F81FD0307C}</a:tableStyleId>
               </a:tblPr>
               <a:tblGrid>
-                <a:gridCol w="6538934"/>
-                <a:gridCol w="1357987"/>
-                <a:gridCol w="1876082"/>
-                <a:gridCol w="1357987"/>
+                <a:gridCol w="7189490"/>
+                <a:gridCol w="914400"/>
+                <a:gridCol w="2112701"/>
+                <a:gridCol w="914400"/>
               </a:tblGrid>
-              <a:tr h="335280">
+              <a:tr h="310896">
                 <a:tc>
                   <a:txBody>
                     <a:bodyPr/>
                     <a:lstStyle/>
                     <a:p>
                       <a:r>
-                        <a:rPr sz="1250" b="1" i="0">
+                        <a:rPr sz="1050" b="1" i="0">
                           <a:solidFill>
                             <a:srgbClr val="FFFFFF"/>
                           </a:solidFill>
@@ -24210,7 +24255,7 @@
                     <a:lstStyle/>
                     <a:p>
                       <a:r>
-                        <a:rPr sz="1250" b="1" i="0">
+                        <a:rPr sz="1050" b="1" i="0">
                           <a:solidFill>
                             <a:srgbClr val="FFFFFF"/>
                           </a:solidFill>
@@ -24232,7 +24277,7 @@
                     <a:lstStyle/>
                     <a:p>
                       <a:r>
-                        <a:rPr sz="1250" b="1" i="0">
+                        <a:rPr sz="1050" b="1" i="0">
                           <a:solidFill>
                             <a:srgbClr val="FFFFFF"/>
                           </a:solidFill>
@@ -24254,7 +24299,7 @@
                     <a:lstStyle/>
                     <a:p>
                       <a:r>
-                        <a:rPr sz="1250" b="1" i="0">
+                        <a:rPr sz="1050" b="1" i="0">
                           <a:solidFill>
                             <a:srgbClr val="FFFFFF"/>
                           </a:solidFill>
@@ -24271,14 +24316,14 @@
                   </a:tcPr>
                 </a:tc>
               </a:tr>
-              <a:tr h="335280">
+              <a:tr h="310896">
                 <a:tc>
                   <a:txBody>
                     <a:bodyPr/>
                     <a:lstStyle/>
                     <a:p>
                       <a:r>
-                        <a:rPr sz="1200" b="0" i="0">
+                        <a:rPr sz="1000" b="0" i="0">
                           <a:solidFill>
                             <a:srgbClr val="1A1440"/>
                           </a:solidFill>
@@ -24300,7 +24345,7 @@
                     <a:lstStyle/>
                     <a:p>
                       <a:r>
-                        <a:rPr sz="1200" b="0" i="0">
+                        <a:rPr sz="1000" b="0" i="0">
                           <a:solidFill>
                             <a:srgbClr val="1A1440"/>
                           </a:solidFill>
@@ -24322,7 +24367,7 @@
                     <a:lstStyle/>
                     <a:p>
                       <a:r>
-                        <a:rPr sz="1200" b="0" i="0">
+                        <a:rPr sz="1000" b="0" i="0">
                           <a:solidFill>
                             <a:srgbClr val="1A1440"/>
                           </a:solidFill>
@@ -24344,7 +24389,7 @@
                     <a:lstStyle/>
                     <a:p>
                       <a:r>
-                        <a:rPr sz="1200" b="0" i="0">
+                        <a:rPr sz="1000" b="0" i="0">
                           <a:solidFill>
                             <a:srgbClr val="1A1440"/>
                           </a:solidFill>
@@ -24361,14 +24406,14 @@
                   </a:tcPr>
                 </a:tc>
               </a:tr>
-              <a:tr h="335280">
+              <a:tr h="310896">
                 <a:tc>
                   <a:txBody>
                     <a:bodyPr/>
                     <a:lstStyle/>
                     <a:p>
                       <a:r>
-                        <a:rPr sz="1200" b="0" i="0">
+                        <a:rPr sz="1000" b="0" i="0">
                           <a:solidFill>
                             <a:srgbClr val="1A1440"/>
                           </a:solidFill>
@@ -24390,7 +24435,7 @@
                     <a:lstStyle/>
                     <a:p>
                       <a:r>
-                        <a:rPr sz="1200" b="0" i="0">
+                        <a:rPr sz="1000" b="0" i="0">
                           <a:solidFill>
                             <a:srgbClr val="1A1440"/>
                           </a:solidFill>
@@ -24412,7 +24457,7 @@
                     <a:lstStyle/>
                     <a:p>
                       <a:r>
-                        <a:rPr sz="1200" b="0" i="0">
+                        <a:rPr sz="1000" b="0" i="0">
                           <a:solidFill>
                             <a:srgbClr val="1A1440"/>
                           </a:solidFill>
@@ -24434,7 +24479,7 @@
                     <a:lstStyle/>
                     <a:p>
                       <a:r>
-                        <a:rPr sz="1200" b="0" i="0">
+                        <a:rPr sz="1000" b="0" i="0">
                           <a:solidFill>
                             <a:srgbClr val="1A1440"/>
                           </a:solidFill>
@@ -24451,14 +24496,14 @@
                   </a:tcPr>
                 </a:tc>
               </a:tr>
-              <a:tr h="335280">
+              <a:tr h="310896">
                 <a:tc>
                   <a:txBody>
                     <a:bodyPr/>
                     <a:lstStyle/>
                     <a:p>
                       <a:r>
-                        <a:rPr sz="1200" b="0" i="0">
+                        <a:rPr sz="1000" b="0" i="0">
                           <a:solidFill>
                             <a:srgbClr val="1A1440"/>
                           </a:solidFill>
@@ -24480,7 +24525,7 @@
                     <a:lstStyle/>
                     <a:p>
                       <a:r>
-                        <a:rPr sz="1200" b="0" i="0">
+                        <a:rPr sz="1000" b="0" i="0">
                           <a:solidFill>
                             <a:srgbClr val="1A1440"/>
                           </a:solidFill>
@@ -24502,7 +24547,7 @@
                     <a:lstStyle/>
                     <a:p>
                       <a:r>
-                        <a:rPr sz="1200" b="0" i="0">
+                        <a:rPr sz="1000" b="0" i="0">
                           <a:solidFill>
                             <a:srgbClr val="1A1440"/>
                           </a:solidFill>
@@ -24524,7 +24569,7 @@
                     <a:lstStyle/>
                     <a:p>
                       <a:r>
-                        <a:rPr sz="1200" b="0" i="0">
+                        <a:rPr sz="1000" b="0" i="0">
                           <a:solidFill>
                             <a:srgbClr val="1A1440"/>
                           </a:solidFill>
@@ -24541,14 +24586,14 @@
                   </a:tcPr>
                 </a:tc>
               </a:tr>
-              <a:tr h="335280">
+              <a:tr h="310896">
                 <a:tc>
                   <a:txBody>
                     <a:bodyPr/>
                     <a:lstStyle/>
                     <a:p>
                       <a:r>
-                        <a:rPr sz="1200" b="0" i="0">
+                        <a:rPr sz="1000" b="0" i="0">
                           <a:solidFill>
                             <a:srgbClr val="1A1440"/>
                           </a:solidFill>
@@ -24570,7 +24615,7 @@
                     <a:lstStyle/>
                     <a:p>
                       <a:r>
-                        <a:rPr sz="1200" b="0" i="0">
+                        <a:rPr sz="1000" b="0" i="0">
                           <a:solidFill>
                             <a:srgbClr val="1A1440"/>
                           </a:solidFill>
@@ -24592,7 +24637,7 @@
                     <a:lstStyle/>
                     <a:p>
                       <a:r>
-                        <a:rPr sz="1200" b="0" i="0">
+                        <a:rPr sz="1000" b="0" i="0">
                           <a:solidFill>
                             <a:srgbClr val="1A1440"/>
                           </a:solidFill>
@@ -24614,7 +24659,7 @@
                     <a:lstStyle/>
                     <a:p>
                       <a:r>
-                        <a:rPr sz="1200" b="0" i="0">
+                        <a:rPr sz="1000" b="0" i="0">
                           <a:solidFill>
                             <a:srgbClr val="1A1440"/>
                           </a:solidFill>
@@ -24643,8 +24688,8 @@
         </p:nvSpPr>
         <p:spPr>
           <a:xfrm>
-            <a:off x="530352" y="3837940"/>
-            <a:ext cx="11130991" cy="1048512"/>
+            <a:off x="530352" y="3623056"/>
+            <a:ext cx="11130991" cy="1428496"/>
           </a:xfrm>
           <a:prstGeom prst="rect">
             <a:avLst/>
@@ -24659,17 +24704,17 @@
           <a:p>
             <a:pPr>
               <a:spcAft>
-                <a:spcPts val="800"/>
+                <a:spcPts val="700"/>
               </a:spcAft>
             </a:pPr>
             <a:r>
-              <a:rPr sz="1600" b="0" i="0">
+              <a:rPr sz="1400" b="0" i="0">
                 <a:solidFill>
                   <a:srgbClr val="1A1440"/>
                 </a:solidFill>
                 <a:latin typeface="Calibri"/>
               </a:rPr>
-              <a:t>Since 80 percent of those who accept join, 60 fewer acceptances are 48 fewer students, and the joiners counted directly say the same: 288 last cycle, 240 this cycle. At a first-year fee of Rs 1 to 1.5 lakh, an assumption, that is Rs 48 to 72 lakh of fee income a year, Rs 57.6 lakh at Rs 1.2 lakh.</a:t>
+              <a:t>Since 80 percent of those who accept join, 60 fewer acceptances are 48 fewer students, and the joiners counted directly say the same: 288 last cycle, 240 this cycle. At a first-year fee of Rs 1 to 1.5 lakh, an assumption, that is Rs 48 to 72 lakh of first-year fees, Rs 57.6 lakh at Rs 1.2 lakh. The no-show, sized the same way: if half of the 200 sat the test and passed on at this cycle's rates, an assumption, about 30 more would join. That gain is worth planning for, and it is how the test has always run; the 48 is a loss that started this cycle.</a:t>
             </a:r>
           </a:p>
         </p:txBody>
@@ -24682,8 +24727,8 @@
         </p:nvSpPr>
         <p:spPr>
           <a:xfrm>
-            <a:off x="530352" y="5014467"/>
-            <a:ext cx="11130991" cy="962152"/>
+            <a:off x="530352" y="5179568"/>
+            <a:ext cx="11130991" cy="890016"/>
           </a:xfrm>
           <a:prstGeom prst="roundRect">
             <a:avLst>
@@ -24734,7 +24779,7 @@
         </p:nvSpPr>
         <p:spPr>
           <a:xfrm>
-            <a:off x="713232" y="5142483"/>
+            <a:off x="713232" y="5307584"/>
             <a:ext cx="91440" cy="91440"/>
           </a:xfrm>
           <a:prstGeom prst="ellipse">
@@ -24778,7 +24823,7 @@
         </p:nvSpPr>
         <p:spPr>
           <a:xfrm>
-            <a:off x="868680" y="5142483"/>
+            <a:off x="868680" y="5307584"/>
             <a:ext cx="91440" cy="91440"/>
           </a:xfrm>
           <a:prstGeom prst="ellipse">
@@ -24822,7 +24867,7 @@
         </p:nvSpPr>
         <p:spPr>
           <a:xfrm>
-            <a:off x="1024128" y="5142483"/>
+            <a:off x="1024128" y="5307584"/>
             <a:ext cx="91440" cy="91440"/>
           </a:xfrm>
           <a:prstGeom prst="ellipse">
@@ -24866,8 +24911,8 @@
         </p:nvSpPr>
         <p:spPr>
           <a:xfrm>
-            <a:off x="804671" y="5343652"/>
-            <a:ext cx="10673791" cy="559816"/>
+            <a:off x="804671" y="5508752"/>
+            <a:ext cx="10673791" cy="487679"/>
           </a:xfrm>
           <a:prstGeom prst="rect">
             <a:avLst/>
@@ -24886,13 +24931,13 @@
               </a:spcAft>
             </a:pPr>
             <a:r>
-              <a:rPr sz="1400" b="0" i="0">
+              <a:rPr sz="1200" b="0" i="0">
                 <a:solidFill>
                   <a:srgbClr val="E4E1F1"/>
                 </a:solidFill>
                 <a:latin typeface="Consolas"/>
               </a:rPr>
-              <a:t>lost = (shortlisted * last_cycle_rate - accepted).round()   # 5 in-state, 55 other states</a:t>
+              <a:t>lost = shortlisted * accepted_last / shortlisted_last - accepted   # 230 - 225 = 5; 130 - 75 = 55</a:t>
             </a:r>
           </a:p>
           <a:p>
@@ -24902,13 +24947,13 @@
               </a:spcAft>
             </a:pPr>
             <a:r>
-              <a:rPr sz="1400" b="0" i="0">
+              <a:rPr sz="1200" b="0" i="0">
                 <a:solidFill>
                   <a:srgbClr val="E4E1F1"/>
                 </a:solidFill>
                 <a:latin typeface="Consolas"/>
               </a:rPr>
-              <a:t>joiners_lost = lost.sum() * 0.8                              # 48; 288 - 240 says the same</a:t>
+              <a:t>joiners_lost = lost.sum() * 0.8                                    # 48; 288 - 240 says the same</a:t>
             </a:r>
           </a:p>
         </p:txBody>
@@ -26302,7 +26347,7 @@
         </p:nvSpPr>
         <p:spPr>
           <a:xfrm>
-            <a:off x="530352" y="1920240"/>
+            <a:off x="530352" y="1855724"/>
             <a:ext cx="502920" cy="300735"/>
           </a:xfrm>
           <a:prstGeom prst="rect">
@@ -26337,7 +26382,163 @@
         </p:nvSpPr>
         <p:spPr>
           <a:xfrm>
-            <a:off x="1097280" y="1956816"/>
+            <a:off x="1097280" y="1892300"/>
+            <a:ext cx="10564063" cy="558800"/>
+          </a:xfrm>
+          <a:prstGeom prst="rect">
+            <a:avLst/>
+          </a:prstGeom>
+          <a:noFill/>
+        </p:spPr>
+        <p:txBody>
+          <a:bodyPr wrap="square" anchor="t" lIns="0" rIns="0" tIns="0" bIns="0">
+            <a:spAutoFit/>
+          </a:bodyPr>
+          <a:lstStyle/>
+          <a:p>
+            <a:r>
+              <a:rPr sz="1300" b="1" i="0">
+                <a:solidFill>
+                  <a:srgbClr val="1A1440"/>
+                </a:solidFill>
+                <a:latin typeface="Calibri"/>
+              </a:rPr>
+              <a:t>The call.</a:t>
+            </a:r>
+            <a:r>
+              <a:rPr sz="1300" b="0" i="0">
+                <a:solidFill>
+                  <a:srgbClr val="1A1440"/>
+                </a:solidFill>
+                <a:latin typeface="Calibri"/>
+              </a:rPr>
+              <a:t> Give other-state offers their 21-day fee deadline back in the next round, a cheap change that can be undone; the test's no-show waits, since it never moved.</a:t>
+            </a:r>
+          </a:p>
+        </p:txBody>
+      </p:sp>
+      <p:sp>
+        <p:nvSpPr>
+          <p:cNvPr id="11" name="TextBox 10"/>
+          <p:cNvSpPr txBox="1"/>
+          <p:nvPr/>
+        </p:nvSpPr>
+        <p:spPr>
+          <a:xfrm>
+            <a:off x="530352" y="2487676"/>
+            <a:ext cx="502920" cy="300735"/>
+          </a:xfrm>
+          <a:prstGeom prst="rect">
+            <a:avLst/>
+          </a:prstGeom>
+          <a:noFill/>
+        </p:spPr>
+        <p:txBody>
+          <a:bodyPr wrap="square" anchor="t" lIns="0" rIns="0" tIns="0" bIns="0">
+            <a:spAutoFit/>
+          </a:bodyPr>
+          <a:lstStyle/>
+          <a:p>
+            <a:pPr algn="l"/>
+            <a:r>
+              <a:rPr sz="1600" b="0" i="0">
+                <a:solidFill>
+                  <a:srgbClr val="5B3FD6"/>
+                </a:solidFill>
+                <a:latin typeface="Georgia"/>
+              </a:rPr>
+              <a:t>02</a:t>
+            </a:r>
+          </a:p>
+        </p:txBody>
+      </p:sp>
+      <p:sp>
+        <p:nvSpPr>
+          <p:cNvPr id="12" name="TextBox 11"/>
+          <p:cNvSpPr txBox="1"/>
+          <p:nvPr/>
+        </p:nvSpPr>
+        <p:spPr>
+          <a:xfrm>
+            <a:off x="1097280" y="2524252"/>
+            <a:ext cx="10564063" cy="558800"/>
+          </a:xfrm>
+          <a:prstGeom prst="rect">
+            <a:avLst/>
+          </a:prstGeom>
+          <a:noFill/>
+        </p:spPr>
+        <p:txBody>
+          <a:bodyPr wrap="square" anchor="t" lIns="0" rIns="0" tIns="0" bIns="0">
+            <a:spAutoFit/>
+          </a:bodyPr>
+          <a:lstStyle/>
+          <a:p>
+            <a:r>
+              <a:rPr sz="1300" b="1" i="0">
+                <a:solidFill>
+                  <a:srgbClr val="1A1440"/>
+                </a:solidFill>
+                <a:latin typeface="Calibri"/>
+              </a:rPr>
+              <a:t>The evidence.</a:t>
+            </a:r>
+            <a:r>
+              <a:rPr sz="1300" b="0" i="0">
+                <a:solidFill>
+                  <a:srgbClr val="1A1440"/>
+                </a:solidFill>
+                <a:latin typeface="Calibri"/>
+              </a:rPr>
+              <a:t> Offer acceptance fell from 90 to 75 percent; for other-state students from 87 to 50, while in-state held at 92 to 90 on the same step, from the cycle the deadline went from 21 to 7 days.</a:t>
+            </a:r>
+          </a:p>
+        </p:txBody>
+      </p:sp>
+      <p:sp>
+        <p:nvSpPr>
+          <p:cNvPr id="13" name="TextBox 12"/>
+          <p:cNvSpPr txBox="1"/>
+          <p:nvPr/>
+        </p:nvSpPr>
+        <p:spPr>
+          <a:xfrm>
+            <a:off x="530352" y="3119628"/>
+            <a:ext cx="502920" cy="300735"/>
+          </a:xfrm>
+          <a:prstGeom prst="rect">
+            <a:avLst/>
+          </a:prstGeom>
+          <a:noFill/>
+        </p:spPr>
+        <p:txBody>
+          <a:bodyPr wrap="square" anchor="t" lIns="0" rIns="0" tIns="0" bIns="0">
+            <a:spAutoFit/>
+          </a:bodyPr>
+          <a:lstStyle/>
+          <a:p>
+            <a:pPr algn="l"/>
+            <a:r>
+              <a:rPr sz="1600" b="0" i="0">
+                <a:solidFill>
+                  <a:srgbClr val="5B3FD6"/>
+                </a:solidFill>
+                <a:latin typeface="Georgia"/>
+              </a:rPr>
+              <a:t>03</a:t>
+            </a:r>
+          </a:p>
+        </p:txBody>
+      </p:sp>
+      <p:sp>
+        <p:nvSpPr>
+          <p:cNvPr id="14" name="TextBox 13"/>
+          <p:cNvSpPr txBox="1"/>
+          <p:nvPr/>
+        </p:nvSpPr>
+        <p:spPr>
+          <a:xfrm>
+            <a:off x="1097280" y="3156204"/>
             <a:ext cx="10564063" cy="334264"/>
           </a:xfrm>
           <a:prstGeom prst="rect">
@@ -26358,7 +26559,7 @@
                 </a:solidFill>
                 <a:latin typeface="Calibri"/>
               </a:rPr>
-              <a:t>The call.</a:t>
+              <a:t>The cost.</a:t>
             </a:r>
             <a:r>
               <a:rPr sz="1300" b="0" i="0">
@@ -26367,20 +26568,20 @@
                 </a:solidFill>
                 <a:latin typeface="Calibri"/>
               </a:rPr>
-              <a:t> Give other-state offers a longer fee deadline first; the test's no-show waits, since it never moved.</a:t>
-            </a:r>
-          </a:p>
-        </p:txBody>
-      </p:sp>
-      <p:sp>
-        <p:nvSpPr>
-          <p:cNvPr id="11" name="TextBox 10"/>
-          <p:cNvSpPr txBox="1"/>
-          <p:nvPr/>
-        </p:nvSpPr>
-        <p:spPr>
-          <a:xfrm>
-            <a:off x="530352" y="2327656"/>
+              <a:t> 60 fewer acceptances, 48 fewer students, Rs 48 to 72 lakh of first-year fees at an assumed Rs 1 to 1.5 lakh.</a:t>
+            </a:r>
+          </a:p>
+        </p:txBody>
+      </p:sp>
+      <p:sp>
+        <p:nvSpPr>
+          <p:cNvPr id="15" name="TextBox 14"/>
+          <p:cNvSpPr txBox="1"/>
+          <p:nvPr/>
+        </p:nvSpPr>
+        <p:spPr>
+          <a:xfrm>
+            <a:off x="530352" y="3527044"/>
             <a:ext cx="502920" cy="300735"/>
           </a:xfrm>
           <a:prstGeom prst="rect">
@@ -26402,20 +26603,20 @@
                 </a:solidFill>
                 <a:latin typeface="Georgia"/>
               </a:rPr>
-              <a:t>02</a:t>
-            </a:r>
-          </a:p>
-        </p:txBody>
-      </p:sp>
-      <p:sp>
-        <p:nvSpPr>
-          <p:cNvPr id="12" name="TextBox 11"/>
-          <p:cNvSpPr txBox="1"/>
-          <p:nvPr/>
-        </p:nvSpPr>
-        <p:spPr>
-          <a:xfrm>
-            <a:off x="1097280" y="2364232"/>
+              <a:t>04</a:t>
+            </a:r>
+          </a:p>
+        </p:txBody>
+      </p:sp>
+      <p:sp>
+        <p:nvSpPr>
+          <p:cNvPr id="16" name="TextBox 15"/>
+          <p:cNvSpPr txBox="1"/>
+          <p:nvPr/>
+        </p:nvSpPr>
+        <p:spPr>
+          <a:xfrm>
+            <a:off x="1097280" y="3563620"/>
             <a:ext cx="10564063" cy="558800"/>
           </a:xfrm>
           <a:prstGeom prst="rect">
@@ -26436,7 +26637,7 @@
                 </a:solidFill>
                 <a:latin typeface="Calibri"/>
               </a:rPr>
-              <a:t>The evidence.</a:t>
+              <a:t>The objection.</a:t>
             </a:r>
             <a:r>
               <a:rPr sz="1300" b="0" i="0">
@@ -26445,20 +26646,20 @@
                 </a:solidFill>
                 <a:latin typeface="Calibri"/>
               </a:rPr>
-              <a:t> Offer acceptance fell from 90 to 75 percent; for other-state students from 87 to 50, while in-state held at 92 to 90 on the same step, from the cycle the deadline went from 21 to 7 days.</a:t>
-            </a:r>
-          </a:p>
-        </p:txBody>
-      </p:sp>
-      <p:sp>
-        <p:nvSpPr>
-          <p:cNvPr id="13" name="TextBox 12"/>
-          <p:cNvSpPr txBox="1"/>
-          <p:nvPr/>
-        </p:nvSpPr>
-        <p:spPr>
-          <a:xfrm>
-            <a:off x="530352" y="2959608"/>
+              <a:t> Offers did go out in two days, which is true; the fall came after the offer, for one group, after one change.</a:t>
+            </a:r>
+          </a:p>
+        </p:txBody>
+      </p:sp>
+      <p:sp>
+        <p:nvSpPr>
+          <p:cNvPr id="17" name="TextBox 16"/>
+          <p:cNvSpPr txBox="1"/>
+          <p:nvPr/>
+        </p:nvSpPr>
+        <p:spPr>
+          <a:xfrm>
+            <a:off x="530352" y="4158996"/>
             <a:ext cx="502920" cy="300735"/>
           </a:xfrm>
           <a:prstGeom prst="rect">
@@ -26480,162 +26681,6 @@
                 </a:solidFill>
                 <a:latin typeface="Georgia"/>
               </a:rPr>
-              <a:t>03</a:t>
-            </a:r>
-          </a:p>
-        </p:txBody>
-      </p:sp>
-      <p:sp>
-        <p:nvSpPr>
-          <p:cNvPr id="14" name="TextBox 13"/>
-          <p:cNvSpPr txBox="1"/>
-          <p:nvPr/>
-        </p:nvSpPr>
-        <p:spPr>
-          <a:xfrm>
-            <a:off x="1097280" y="2996184"/>
-            <a:ext cx="10564063" cy="334264"/>
-          </a:xfrm>
-          <a:prstGeom prst="rect">
-            <a:avLst/>
-          </a:prstGeom>
-          <a:noFill/>
-        </p:spPr>
-        <p:txBody>
-          <a:bodyPr wrap="square" anchor="t" lIns="0" rIns="0" tIns="0" bIns="0">
-            <a:spAutoFit/>
-          </a:bodyPr>
-          <a:lstStyle/>
-          <a:p>
-            <a:r>
-              <a:rPr sz="1300" b="1" i="0">
-                <a:solidFill>
-                  <a:srgbClr val="1A1440"/>
-                </a:solidFill>
-                <a:latin typeface="Calibri"/>
-              </a:rPr>
-              <a:t>The cost.</a:t>
-            </a:r>
-            <a:r>
-              <a:rPr sz="1300" b="0" i="0">
-                <a:solidFill>
-                  <a:srgbClr val="1A1440"/>
-                </a:solidFill>
-                <a:latin typeface="Calibri"/>
-              </a:rPr>
-              <a:t> 60 fewer acceptances, 48 fewer students, Rs 48 to 72 lakh of first-year fees at an assumed Rs 1 to 1.5 lakh.</a:t>
-            </a:r>
-          </a:p>
-        </p:txBody>
-      </p:sp>
-      <p:sp>
-        <p:nvSpPr>
-          <p:cNvPr id="15" name="TextBox 14"/>
-          <p:cNvSpPr txBox="1"/>
-          <p:nvPr/>
-        </p:nvSpPr>
-        <p:spPr>
-          <a:xfrm>
-            <a:off x="530352" y="3367024"/>
-            <a:ext cx="502920" cy="300735"/>
-          </a:xfrm>
-          <a:prstGeom prst="rect">
-            <a:avLst/>
-          </a:prstGeom>
-          <a:noFill/>
-        </p:spPr>
-        <p:txBody>
-          <a:bodyPr wrap="square" anchor="t" lIns="0" rIns="0" tIns="0" bIns="0">
-            <a:spAutoFit/>
-          </a:bodyPr>
-          <a:lstStyle/>
-          <a:p>
-            <a:pPr algn="l"/>
-            <a:r>
-              <a:rPr sz="1600" b="0" i="0">
-                <a:solidFill>
-                  <a:srgbClr val="5B3FD6"/>
-                </a:solidFill>
-                <a:latin typeface="Georgia"/>
-              </a:rPr>
-              <a:t>04</a:t>
-            </a:r>
-          </a:p>
-        </p:txBody>
-      </p:sp>
-      <p:sp>
-        <p:nvSpPr>
-          <p:cNvPr id="16" name="TextBox 15"/>
-          <p:cNvSpPr txBox="1"/>
-          <p:nvPr/>
-        </p:nvSpPr>
-        <p:spPr>
-          <a:xfrm>
-            <a:off x="1097280" y="3403600"/>
-            <a:ext cx="10564063" cy="558800"/>
-          </a:xfrm>
-          <a:prstGeom prst="rect">
-            <a:avLst/>
-          </a:prstGeom>
-          <a:noFill/>
-        </p:spPr>
-        <p:txBody>
-          <a:bodyPr wrap="square" anchor="t" lIns="0" rIns="0" tIns="0" bIns="0">
-            <a:spAutoFit/>
-          </a:bodyPr>
-          <a:lstStyle/>
-          <a:p>
-            <a:r>
-              <a:rPr sz="1300" b="1" i="0">
-                <a:solidFill>
-                  <a:srgbClr val="1A1440"/>
-                </a:solidFill>
-                <a:latin typeface="Calibri"/>
-              </a:rPr>
-              <a:t>The objection.</a:t>
-            </a:r>
-            <a:r>
-              <a:rPr sz="1300" b="0" i="0">
-                <a:solidFill>
-                  <a:srgbClr val="1A1440"/>
-                </a:solidFill>
-                <a:latin typeface="Calibri"/>
-              </a:rPr>
-              <a:t> Offers did go out in two days, which is true; the fall came after the offer, for one group, after one change.</a:t>
-            </a:r>
-          </a:p>
-        </p:txBody>
-      </p:sp>
-      <p:sp>
-        <p:nvSpPr>
-          <p:cNvPr id="17" name="TextBox 16"/>
-          <p:cNvSpPr txBox="1"/>
-          <p:nvPr/>
-        </p:nvSpPr>
-        <p:spPr>
-          <a:xfrm>
-            <a:off x="530352" y="3998976"/>
-            <a:ext cx="502920" cy="300735"/>
-          </a:xfrm>
-          <a:prstGeom prst="rect">
-            <a:avLst/>
-          </a:prstGeom>
-          <a:noFill/>
-        </p:spPr>
-        <p:txBody>
-          <a:bodyPr wrap="square" anchor="t" lIns="0" rIns="0" tIns="0" bIns="0">
-            <a:spAutoFit/>
-          </a:bodyPr>
-          <a:lstStyle/>
-          <a:p>
-            <a:pPr algn="l"/>
-            <a:r>
-              <a:rPr sz="1600" b="0" i="0">
-                <a:solidFill>
-                  <a:srgbClr val="5B3FD6"/>
-                </a:solidFill>
-                <a:latin typeface="Georgia"/>
-              </a:rPr>
               <a:t>05</a:t>
             </a:r>
           </a:p>
@@ -26649,7 +26694,7 @@
         </p:nvSpPr>
         <p:spPr>
           <a:xfrm>
-            <a:off x="1097280" y="4035552"/>
+            <a:off x="1097280" y="4195572"/>
             <a:ext cx="10564063" cy="558800"/>
           </a:xfrm>
           <a:prstGeom prst="rect">
@@ -26692,7 +26737,7 @@
         </p:nvSpPr>
         <p:spPr>
           <a:xfrm>
-            <a:off x="530352" y="4777232"/>
+            <a:off x="530352" y="4937252"/>
             <a:ext cx="11130991" cy="1052576"/>
           </a:xfrm>
           <a:prstGeom prst="roundRect">
@@ -26746,7 +26791,7 @@
         </p:nvSpPr>
         <p:spPr>
           <a:xfrm>
-            <a:off x="758952" y="5074920"/>
+            <a:off x="758952" y="5234940"/>
             <a:ext cx="457200" cy="457200"/>
           </a:xfrm>
           <a:prstGeom prst="ellipse">
@@ -26798,7 +26843,7 @@
         </p:blipFill>
         <p:spPr>
           <a:xfrm>
-            <a:off x="868680" y="5184648"/>
+            <a:off x="868680" y="5344668"/>
             <a:ext cx="237744" cy="237744"/>
           </a:xfrm>
           <a:prstGeom prst="rect">
@@ -26814,7 +26859,7 @@
         </p:nvSpPr>
         <p:spPr>
           <a:xfrm>
-            <a:off x="1399031" y="4923536"/>
+            <a:off x="1399031" y="5083556"/>
             <a:ext cx="9987991" cy="160401"/>
           </a:xfrm>
           <a:prstGeom prst="rect">
@@ -26849,7 +26894,7 @@
         </p:nvSpPr>
         <p:spPr>
           <a:xfrm>
-            <a:off x="1399031" y="5142992"/>
+            <a:off x="1399031" y="5303012"/>
             <a:ext cx="9987991" cy="613664"/>
           </a:xfrm>
           <a:prstGeom prst="rect">

</xml_diff>